<commit_message>
Translate presentation to Portuguese, keep English backup
- ToggleMaster-Phase4-Presentation.pptx: fully translated to pt-BR (140 texts + all speaker notes)
- ToggleMaster-Phase4-Presentation-en.pptx: original English version preserved
</commit_message>
<xml_diff>
--- a/docs/ToggleMaster-Phase4-Presentation.pptx
+++ b/docs/ToggleMaster-Phase4-Presentation.pptx
@@ -513,12 +513,18 @@
           <a:lstStyle/>
           <a:p>
             <a:r>
-              <a:rPr lang="en-US" dirty="0"/>
-              <a:t>Title slide. Introduce yourself, team members, RMs.
-Project: ToggleMaster - feature flag platform.
-Phase 4 focus: adding full observability and self-healing to the existing CI/CD + GitOps infrastructure.</a:t>
-            </a:r>
-            <a:endParaRPr lang="en-US" dirty="0"/>
+              <a:t>Slide de título. Apresente-se, os membros da equipe e os RMs.</a:t>
+            </a:r>
+          </a:p>
+          <a:p>
+            <a:r>
+              <a:t>Projeto: ToggleMaster - plataforma de feature flags.</a:t>
+            </a:r>
+          </a:p>
+          <a:p>
+            <a:r>
+              <a:t>Foco da Fase 4: adicionar observabilidade completa e auto-recuperação à infraestrutura CI/CD + GitOps existente.</a:t>
+            </a:r>
           </a:p>
         </p:txBody>
       </p:sp>
@@ -603,13 +609,23 @@
           <a:lstStyle/>
           <a:p>
             <a:r>
-              <a:rPr lang="en-US" dirty="0"/>
-              <a:t>Brief slide (~1 min). Explain the reasoning:
-- New Relic: free tier is generous, OTLP means no vendor lock-in
-- PagerDuty: Events API v2 is straightforward, free tier has enough features
-- OTel: the whole point is standardization - tomorrow we could switch to Datadog by changing 1 exporter config</a:t>
-            </a:r>
-            <a:endParaRPr lang="en-US" dirty="0"/>
+              <a:t>Slide breve (~1 min). Explique o raciocínio:</a:t>
+            </a:r>
+          </a:p>
+          <a:p>
+            <a:r>
+              <a:t>- New Relic: o plano gratuito é generoso, OTLP significa sem dependência de fornecedor</a:t>
+            </a:r>
+          </a:p>
+          <a:p>
+            <a:r>
+              <a:t>- PagerDuty: a Events API v2 é direta, o plano gratuito tem recursos suficientes</a:t>
+            </a:r>
+          </a:p>
+          <a:p>
+            <a:r>
+              <a:t>- OTel: o objetivo é a padronização - amanhã poderíamos migrar para o Datadog mudando apenas 1 configuração de exportador</a:t>
+            </a:r>
           </a:p>
         </p:txBody>
       </p:sp>
@@ -694,14 +710,28 @@
           <a:lstStyle/>
           <a:p>
             <a:r>
-              <a:rPr lang="en-US" dirty="0"/>
-              <a:t>Quick slide. Emphasize defense in depth:
-- HPA scales automatically under load
-- PDB prevents disruptions during node maintenance
-- Probes detect unhealthy pods and restart them
-- 2 replicas = zero downtime during rolling updates</a:t>
-            </a:r>
-            <a:endParaRPr lang="en-US" dirty="0"/>
+              <a:t>Slide rápido. Enfatize a defesa em profundidade:</a:t>
+            </a:r>
+          </a:p>
+          <a:p>
+            <a:r>
+              <a:t>- HPA escala automaticamente sob carga</a:t>
+            </a:r>
+          </a:p>
+          <a:p>
+            <a:r>
+              <a:t>- PDB previne interrupções durante manutenção de nós</a:t>
+            </a:r>
+          </a:p>
+          <a:p>
+            <a:r>
+              <a:t>- Probes detectam pods não saudáveis e os reiniciam</a:t>
+            </a:r>
+          </a:p>
+          <a:p>
+            <a:r>
+              <a:t>- 2 réplicas = zero downtime durante atualizações incrementais</a:t>
+            </a:r>
           </a:p>
         </p:txBody>
       </p:sp>
@@ -786,12 +816,18 @@
           <a:lstStyle/>
           <a:p>
             <a:r>
-              <a:rPr lang="en-US" dirty="0"/>
-              <a:t>Show the repo structure briefly in GitHub.
-Mention: anyone can fork, change their AWS account + GitHub user, and reproduce the entire environment.
-destroy-all.sh was battle-tested and fixed for macOS compatibility (grep -P bug).</a:t>
-            </a:r>
-            <a:endParaRPr lang="en-US" dirty="0"/>
+              <a:t>Mostre a estrutura do repositório brevemente no GitHub.</a:t>
+            </a:r>
+          </a:p>
+          <a:p>
+            <a:r>
+              <a:t>Mencione: qualquer pessoa pode fazer um fork, mudar a conta AWS + usuário GitHub e reproduzir todo o ambiente.</a:t>
+            </a:r>
+          </a:p>
+          <a:p>
+            <a:r>
+              <a:t>O destroy-all.sh foi testado em batalha e corrigido para compatibilidade com macOS (bug grep -P).</a:t>
+            </a:r>
           </a:p>
         </p:txBody>
       </p:sp>
@@ -876,13 +912,23 @@
           <a:lstStyle/>
           <a:p>
             <a:r>
-              <a:rPr lang="en-US" dirty="0"/>
-              <a:t>Wrap up. Recap the 4 key achievements.
-Mention total time taken if relevant.
-Open for questions.
-Thank the professors.</a:t>
-            </a:r>
-            <a:endParaRPr lang="en-US" dirty="0"/>
+              <a:t>Encerre. Recapitule as 4 conquistas principais.</a:t>
+            </a:r>
+          </a:p>
+          <a:p>
+            <a:r>
+              <a:t>Mencione o tempo total gasto se relevante.</a:t>
+            </a:r>
+          </a:p>
+          <a:p>
+            <a:r>
+              <a:t>Abra para perguntas.</a:t>
+            </a:r>
+          </a:p>
+          <a:p>
+            <a:r>
+              <a:t>Agradeça os professores.</a:t>
+            </a:r>
           </a:p>
         </p:txBody>
       </p:sp>
@@ -967,12 +1013,18 @@
           <a:lstStyle/>
           <a:p>
             <a:r>
-              <a:rPr lang="en-US" dirty="0"/>
-              <a:t>Walk through the agenda quickly (~1 min).
-Total video: up to 25 minutes.
-The Self-Healing demo is the highlight - save energy for it.</a:t>
-            </a:r>
-            <a:endParaRPr lang="en-US" dirty="0"/>
+              <a:t>Apresente a agenda rapidamente (~1 min).</a:t>
+            </a:r>
+          </a:p>
+          <a:p>
+            <a:r>
+              <a:t>Vídeo total: até 25 minutos.</a:t>
+            </a:r>
+          </a:p>
+          <a:p>
+            <a:r>
+              <a:t>A demo de Auto-Recuperação é o destaque - guarde energia para ela.</a:t>
+            </a:r>
           </a:p>
         </p:txBody>
       </p:sp>
@@ -1057,13 +1109,23 @@
           <a:lstStyle/>
           <a:p>
             <a:r>
-              <a:rPr lang="en-US" dirty="0"/>
-              <a:t>DEMO ACTION: Show ArgoCD UI - all 7 apps Healthy and Synced.
-Show kubectl get nodes (3 nodes).
-Mention: 2 replicas per service = 10 pods total.
-Highlight: Go (auth + evaluation) vs Python (flag + targeting + analytics) - different OTel metric names.</a:t>
-            </a:r>
-            <a:endParaRPr lang="en-US" dirty="0"/>
+              <a:t>AÇÃO NA DEMO: Mostre a interface do ArgoCD - todos os 7 apps com status Healthy e Synced.</a:t>
+            </a:r>
+          </a:p>
+          <a:p>
+            <a:r>
+              <a:t>Mostre kubectl get nodes (3 nós).</a:t>
+            </a:r>
+          </a:p>
+          <a:p>
+            <a:r>
+              <a:t>Mencione: 2 réplicas por serviço = 10 pods no total.</a:t>
+            </a:r>
+          </a:p>
+          <a:p>
+            <a:r>
+              <a:t>Destaque: Go (auth + evaluation) vs Python (flag + targeting + analytics) - nomes de métricas OTel diferentes.</a:t>
+            </a:r>
           </a:p>
         </p:txBody>
       </p:sp>
@@ -1148,12 +1210,18 @@
           <a:lstStyle/>
           <a:p>
             <a:r>
-              <a:rPr lang="en-US" dirty="0"/>
-              <a:t>DEMO ACTION: Run kubectl get pods -n monitoring (show all 16 pods running).
-Explain each component briefly.
-Key point: all installed via Helm, managed as code in the GitOps repo.</a:t>
-            </a:r>
-            <a:endParaRPr lang="en-US" dirty="0"/>
+              <a:t>AÇÃO NA DEMO: Execute kubectl get pods -n monitoring (mostre todos os 16 pods em execução).</a:t>
+            </a:r>
+          </a:p>
+          <a:p>
+            <a:r>
+              <a:t>Explique cada componente brevemente.</a:t>
+            </a:r>
+          </a:p>
+          <a:p>
+            <a:r>
+              <a:t>Ponto principal: todos instalados via Helm, gerenciados como código no repositório GitOps.</a:t>
+            </a:r>
           </a:p>
         </p:txBody>
       </p:sp>
@@ -1238,13 +1306,23 @@
           <a:lstStyle/>
           <a:p>
             <a:r>
-              <a:rPr lang="en-US" dirty="0"/>
-              <a:t>DEMO ACTION: Show OTel Collector values.yaml in the repo.
-Highlight the 3 pipelines: traces, metrics, logs.
-Key insight: apps only know about OTel endpoint, NOT about Prometheus/Loki/New Relic.
-Mention: otlphttp/newrelic (switched from gRPC for reliability).</a:t>
-            </a:r>
-            <a:endParaRPr lang="en-US" dirty="0"/>
+              <a:t>AÇÃO NA DEMO: Mostre o arquivo values.yaml do OTel Collector no repositório.</a:t>
+            </a:r>
+          </a:p>
+          <a:p>
+            <a:r>
+              <a:t>Destaque os 3 pipelines: traces, metrics, logs.</a:t>
+            </a:r>
+          </a:p>
+          <a:p>
+            <a:r>
+              <a:t>Insight principal: os apps conhecem apenas o endpoint OTel, NÃO o Prometheus/Loki/New Relic.</a:t>
+            </a:r>
+          </a:p>
+          <a:p>
+            <a:r>
+              <a:t>Mencione: otlphttp/newrelic (migrado de gRPC para maior confiabilidade).</a:t>
+            </a:r>
           </a:p>
         </p:txBody>
       </p:sp>
@@ -1329,14 +1407,28 @@
           <a:lstStyle/>
           <a:p>
             <a:r>
-              <a:rPr lang="en-US" dirty="0"/>
-              <a:t>DEMO ACTION: Open Grafana URL in browser.
-Show each panel one by one.
-Search logs in the Loki panel (type a service name).
-Key point: Go and Python emit DIFFERENT metric names - dashboard handles both.
-Mention: Loki datasource UID is resolved dynamically by install-monitoring.sh.</a:t>
-            </a:r>
-            <a:endParaRPr lang="en-US" dirty="0"/>
+              <a:t>AÇÃO NA DEMO: Abra a URL do Grafana no navegador.</a:t>
+            </a:r>
+          </a:p>
+          <a:p>
+            <a:r>
+              <a:t>Mostre cada painel um a um.</a:t>
+            </a:r>
+          </a:p>
+          <a:p>
+            <a:r>
+              <a:t>Pesquise logs no painel do Loki (digite o nome de um serviço).</a:t>
+            </a:r>
+          </a:p>
+          <a:p>
+            <a:r>
+              <a:t>Ponto principal: Go e Python emitem nomes de métricas DIFERENTES - o dashboard lida com ambos.</a:t>
+            </a:r>
+          </a:p>
+          <a:p>
+            <a:r>
+              <a:t>Mencione: o UID do datasource do Loki é resolvido dinamicamente pelo install-monitoring.sh.</a:t>
+            </a:r>
           </a:p>
         </p:txBody>
       </p:sp>
@@ -1421,16 +1513,38 @@
           <a:lstStyle/>
           <a:p>
             <a:r>
-              <a:rPr lang="en-US" dirty="0"/>
-              <a:t>DEMO ACTION: Open New Relic in browser.
-1. Go to APM &amp; Services - show all 5 services listed
-2. Click evaluation-service
-3. Click Service Map in left sidebar - show the dependency graph
-4. Go to Distributed Tracing - pick a trace
-5. Show the waterfall view with timing per service
-Key point: no agent installed - all via OTel Collector + OTLP.</a:t>
-            </a:r>
-            <a:endParaRPr lang="en-US" dirty="0"/>
+              <a:t>AÇÃO NA DEMO: Abra o New Relic no navegador.</a:t>
+            </a:r>
+          </a:p>
+          <a:p>
+            <a:r>
+              <a:t>1. Vá para APM &amp; Services - mostre os 5 serviços listados</a:t>
+            </a:r>
+          </a:p>
+          <a:p>
+            <a:r>
+              <a:t>2. Clique em evaluation-service</a:t>
+            </a:r>
+          </a:p>
+          <a:p>
+            <a:r>
+              <a:t>3. Clique em Service Map na barra lateral esquerda - mostre o gráfico de dependências</a:t>
+            </a:r>
+          </a:p>
+          <a:p>
+            <a:r>
+              <a:t>4. Vá para Distributed Tracing - escolha um rastreamento</a:t>
+            </a:r>
+          </a:p>
+          <a:p>
+            <a:r>
+              <a:t>5. Mostre a visão em cascata com o tempo por serviço</a:t>
+            </a:r>
+          </a:p>
+          <a:p>
+            <a:r>
+              <a:t>Ponto principal: sem agente instalado - tudo via OTel Collector + OTLP.</a:t>
+            </a:r>
           </a:p>
         </p:txBody>
       </p:sp>
@@ -1515,15 +1629,33 @@
           <a:lstStyle/>
           <a:p>
             <a:r>
-              <a:rPr lang="en-US" dirty="0"/>
-              <a:t>DEMO ACTION:
-1. Show Prometheus UI &gt; Alerts page (show rules)
-2. Show Discord channel with past alert notifications
-3. Briefly explain routing: critical goes to PagerDuty (wake up the team) + Discord.
-4. Mention: Watchdog silenced (it's a heartbeat, not actionable)
-5. Mention: KubeControllerManagerDown silenced (expected in managed EKS - no access to control plane)</a:t>
-            </a:r>
-            <a:endParaRPr lang="en-US" dirty="0"/>
+              <a:t>AÇÃO NA DEMO:</a:t>
+            </a:r>
+          </a:p>
+          <a:p>
+            <a:r>
+              <a:t>1. Mostre a interface do Prometheus &gt; página de Alertas (mostre as regras)</a:t>
+            </a:r>
+          </a:p>
+          <a:p>
+            <a:r>
+              <a:t>2. Mostre o canal Discord com as notificações de alertas anteriores</a:t>
+            </a:r>
+          </a:p>
+          <a:p>
+            <a:r>
+              <a:t>3. Explique brevemente o roteamento: crítico vai para o PagerDuty (acorda a equipe) + Discord.</a:t>
+            </a:r>
+          </a:p>
+          <a:p>
+            <a:r>
+              <a:t>4. Mencione: Watchdog silenciado (é um heartbeat, não requer ação)</a:t>
+            </a:r>
+          </a:p>
+          <a:p>
+            <a:r>
+              <a:t>5. Mencione: KubeControllerManagerDown silenciado (esperado no EKS gerenciado - sem acesso ao control plane)</a:t>
+            </a:r>
           </a:p>
         </p:txBody>
       </p:sp>
@@ -1608,20 +1740,61 @@
           <a:lstStyle/>
           <a:p>
             <a:r>
-              <a:rPr lang="en-US" dirty="0"/>
-              <a:t>THIS IS THE MOST IMPORTANT SLIDE - DO THIS LIVE!
-Have terminal ready. Steps:
-1. kubectl get pods -n togglemaster -l app=auth-service   (show 2 pods running)
-2. kubectl scale deployment/auth-service -n togglemaster --replicas=0   (kill it)
-3. kubectl get pods -n togglemaster -l app=auth-service   (show 0 pods)
-4. gh workflow run 'Self-Healing' -f service=auth-service -f alert=PodNotReady
-5. gh run watch &lt;run-id&gt;   (show all steps going green)
-6. kubectl get pods -n togglemaster -l app=auth-service   (show 2 pods back!)
-7. Show Discord: Self-Healing SUCCESS notification
-Alternative if gh CLI not available:
-Go to GitHub &gt; Actions &gt; Self-Healing &gt; Run workflow &gt; select auth-service</a:t>
-            </a:r>
-            <a:endParaRPr lang="en-US" dirty="0"/>
+              <a:t>ESTE É O SLIDE MAIS IMPORTANTE - FAÇA AO VIVO!</a:t>
+            </a:r>
+          </a:p>
+          <a:p/>
+          <a:p>
+            <a:r>
+              <a:t>Tenha o terminal pronto. Passos:</a:t>
+            </a:r>
+          </a:p>
+          <a:p/>
+          <a:p>
+            <a:r>
+              <a:t>1. kubectl get pods -n togglemaster -l app=auth-service   (mostre 2 pods em execução)</a:t>
+            </a:r>
+          </a:p>
+          <a:p>
+            <a:r>
+              <a:t>2. kubectl scale deployment/auth-service -n togglemaster --replicas=0   (derrube)</a:t>
+            </a:r>
+          </a:p>
+          <a:p>
+            <a:r>
+              <a:t>3. kubectl get pods -n togglemaster -l app=auth-service   (mostre 0 pods)</a:t>
+            </a:r>
+          </a:p>
+          <a:p>
+            <a:r>
+              <a:t>4. gh workflow run 'Self-Healing' -f service=auth-service -f alert=PodNotReady</a:t>
+            </a:r>
+          </a:p>
+          <a:p>
+            <a:r>
+              <a:t>5. gh run watch &lt;run-id&gt;   (mostre todos os passos ficando verdes)</a:t>
+            </a:r>
+          </a:p>
+          <a:p>
+            <a:r>
+              <a:t>6. kubectl get pods -n togglemaster -l app=auth-service   (mostre 2 pods de volta!)</a:t>
+            </a:r>
+          </a:p>
+          <a:p>
+            <a:r>
+              <a:t>7. Mostre o Discord: notificação de SUCESSO da Auto-Recuperação</a:t>
+            </a:r>
+          </a:p>
+          <a:p/>
+          <a:p>
+            <a:r>
+              <a:t>Alternativa se o gh CLI não estiver disponível:</a:t>
+            </a:r>
+          </a:p>
+          <a:p>
+            <a:r>
+              <a:t>Vá para GitHub &gt; Actions &gt; Self-Healing &gt; Run workflow &gt; selecione auth-service</a:t>
+            </a:r>
           </a:p>
         </p:txBody>
       </p:sp>
@@ -2011,6 +2184,10 @@
           </a:solidFill>
           <a:ln/>
         </p:spPr>
+        <p:txBody>
+          <a:bodyPr/>
+          <a:p/>
+        </p:txBody>
       </p:sp>
       <p:sp>
         <p:nvSpPr>
@@ -2084,7 +2261,7 @@
                 <a:ea typeface="Calibri" pitchFamily="34" charset="-122"/>
                 <a:cs typeface="Calibri" pitchFamily="34" charset="-120"/>
               </a:rPr>
-              <a:t>Phase 4: Observability &amp; Self-Healing</a:t>
+              <a:t>Fase 4: Observabilidade &amp; Auto-Recuperação</a:t>
             </a:r>
             <a:endParaRPr lang="en-US" sz="2400" dirty="0"/>
           </a:p>
@@ -2123,7 +2300,7 @@
                 <a:ea typeface="Calibri" pitchFamily="34" charset="-122"/>
                 <a:cs typeface="Calibri" pitchFamily="34" charset="-120"/>
               </a:rPr>
-              <a:t>Tech Challenge  |  FIAP Pos Tech  |  DevOps &amp; Software Architecture</a:t>
+              <a:t>Tech Challenge  |  FIAP Pos Tech  |  DevOps &amp; Arquitetura de Software</a:t>
             </a:r>
             <a:endParaRPr lang="en-US" sz="1400" dirty="0"/>
           </a:p>
@@ -2148,6 +2325,10 @@
           </a:solidFill>
           <a:ln/>
         </p:spPr>
+        <p:txBody>
+          <a:bodyPr/>
+          <a:p/>
+        </p:txBody>
       </p:sp>
       <p:sp>
         <p:nvSpPr>
@@ -2253,7 +2434,7 @@
                 <a:ea typeface="Arial Black" pitchFamily="34" charset="-122"/>
                 <a:cs typeface="Arial Black" pitchFamily="34" charset="-120"/>
               </a:rPr>
-              <a:t>Technical Justifications</a:t>
+              <a:t>Justificativas Técnicas</a:t>
             </a:r>
             <a:endParaRPr lang="en-US" sz="3600" dirty="0"/>
           </a:p>
@@ -2285,6 +2466,10 @@
             </a:outerShdw>
           </a:effectLst>
         </p:spPr>
+        <p:txBody>
+          <a:bodyPr/>
+          <a:p/>
+        </p:txBody>
       </p:sp>
       <p:sp>
         <p:nvSpPr>
@@ -2305,6 +2490,10 @@
           </a:solidFill>
           <a:ln/>
         </p:spPr>
+        <p:txBody>
+          <a:bodyPr/>
+          <a:p/>
+        </p:txBody>
       </p:sp>
       <p:sp>
         <p:nvSpPr>
@@ -2339,7 +2528,7 @@
                 <a:ea typeface="Calibri" pitchFamily="34" charset="-122"/>
                 <a:cs typeface="Calibri" pitchFamily="34" charset="-120"/>
               </a:rPr>
-              <a:t>New Relic over Datadog</a:t>
+              <a:t>New Relic vs Datadog</a:t>
             </a:r>
             <a:endParaRPr lang="en-US" sz="1400" dirty="0"/>
           </a:p>
@@ -2376,7 +2565,7 @@
                   <a:srgbClr val="1E293B"/>
                 </a:solidFill>
               </a:rPr>
-              <a:t>Free education tier (100GB/month)</a:t>
+              <a:t>Plano educacional gratuito (100GB/mês)</a:t>
             </a:r>
             <a:endParaRPr lang="en-US" sz="1200" dirty="0"/>
           </a:p>
@@ -2391,7 +2580,7 @@
                   <a:srgbClr val="1E293B"/>
                 </a:solidFill>
               </a:rPr>
-              <a:t>Native OTLP ingest (no proprietary agent)</a:t>
+              <a:t>Ingestão OTLP nativa (sem agente proprietário)</a:t>
             </a:r>
             <a:endParaRPr lang="en-US" sz="1200" dirty="0"/>
           </a:p>
@@ -2406,7 +2595,7 @@
                   <a:srgbClr val="1E293B"/>
                 </a:solidFill>
               </a:rPr>
-              <a:t>Service Map built from OTel traces</a:t>
+              <a:t>Mapa de Serviços construído a partir dos rastreamentos OTel</a:t>
             </a:r>
             <a:endParaRPr lang="en-US" sz="1200" dirty="0"/>
           </a:p>
@@ -2438,6 +2627,10 @@
             </a:outerShdw>
           </a:effectLst>
         </p:spPr>
+        <p:txBody>
+          <a:bodyPr/>
+          <a:p/>
+        </p:txBody>
       </p:sp>
       <p:sp>
         <p:nvSpPr>
@@ -2458,6 +2651,10 @@
           </a:solidFill>
           <a:ln/>
         </p:spPr>
+        <p:txBody>
+          <a:bodyPr/>
+          <a:p/>
+        </p:txBody>
       </p:sp>
       <p:sp>
         <p:nvSpPr>
@@ -2492,7 +2689,7 @@
                 <a:ea typeface="Calibri" pitchFamily="34" charset="-122"/>
                 <a:cs typeface="Calibri" pitchFamily="34" charset="-120"/>
               </a:rPr>
-              <a:t>PagerDuty over OpsGenie</a:t>
+              <a:t>PagerDuty vs OpsGenie</a:t>
             </a:r>
             <a:endParaRPr lang="en-US" sz="1400" dirty="0"/>
           </a:p>
@@ -2529,7 +2726,7 @@
                   <a:srgbClr val="1E293B"/>
                 </a:solidFill>
               </a:rPr>
-              <a:t>Simpler Events API v2</a:t>
+              <a:t>API de Eventos v2 mais simples</a:t>
             </a:r>
             <a:endParaRPr lang="en-US" sz="1200" dirty="0"/>
           </a:p>
@@ -2544,7 +2741,7 @@
                   <a:srgbClr val="1E293B"/>
                 </a:solidFill>
               </a:rPr>
-              <a:t>Better free tier for students</a:t>
+              <a:t>Melhor plano gratuito para estudantes</a:t>
             </a:r>
             <a:endParaRPr lang="en-US" sz="1200" dirty="0"/>
           </a:p>
@@ -2559,7 +2756,7 @@
                   <a:srgbClr val="1E293B"/>
                 </a:solidFill>
               </a:rPr>
-              <a:t>Direct Alertmanager integration</a:t>
+              <a:t>Integração direta com o Alertmanager</a:t>
             </a:r>
             <a:endParaRPr lang="en-US" sz="1200" dirty="0"/>
           </a:p>
@@ -2591,6 +2788,10 @@
             </a:outerShdw>
           </a:effectLst>
         </p:spPr>
+        <p:txBody>
+          <a:bodyPr/>
+          <a:p/>
+        </p:txBody>
       </p:sp>
       <p:sp>
         <p:nvSpPr>
@@ -2611,6 +2812,10 @@
           </a:solidFill>
           <a:ln/>
         </p:spPr>
+        <p:txBody>
+          <a:bodyPr/>
+          <a:p/>
+        </p:txBody>
       </p:sp>
       <p:sp>
         <p:nvSpPr>
@@ -2645,7 +2850,7 @@
                 <a:ea typeface="Calibri" pitchFamily="34" charset="-122"/>
                 <a:cs typeface="Calibri" pitchFamily="34" charset="-120"/>
               </a:rPr>
-              <a:t>OTel Collector over Direct Export</a:t>
+              <a:t>OTel Collector vs Exportação Direta</a:t>
             </a:r>
             <a:endParaRPr lang="en-US" sz="1400" dirty="0"/>
           </a:p>
@@ -2682,7 +2887,7 @@
                   <a:srgbClr val="1E293B"/>
                 </a:solidFill>
               </a:rPr>
-              <a:t>Vendor-neutral standard</a:t>
+              <a:t>Padrão independente de fornecedor</a:t>
             </a:r>
             <a:endParaRPr lang="en-US" sz="1200" dirty="0"/>
           </a:p>
@@ -2697,7 +2902,7 @@
                   <a:srgbClr val="1E293B"/>
                 </a:solidFill>
               </a:rPr>
-              <a:t>Single config point for all backends</a:t>
+              <a:t>Ponto único de configuração para todos os backends</a:t>
             </a:r>
             <a:endParaRPr lang="en-US" sz="1200" dirty="0"/>
           </a:p>
@@ -2712,7 +2917,7 @@
                   <a:srgbClr val="1E293B"/>
                 </a:solidFill>
               </a:rPr>
-              <a:t>Swap New Relic for Datadog = 1 line change</a:t>
+              <a:t>Trocar New Relic por Datadog = 1 linha de código</a:t>
             </a:r>
             <a:endParaRPr lang="en-US" sz="1200" dirty="0"/>
           </a:p>
@@ -2783,7 +2988,7 @@
                 <a:ea typeface="Arial Black" pitchFamily="34" charset="-122"/>
                 <a:cs typeface="Arial Black" pitchFamily="34" charset="-120"/>
               </a:rPr>
-              <a:t>Resilience Features</a:t>
+              <a:t>Recursos de Resiliência</a:t>
             </a:r>
             <a:endParaRPr lang="en-US" sz="3600" dirty="0"/>
           </a:p>
@@ -2815,6 +3020,10 @@
             </a:outerShdw>
           </a:effectLst>
         </p:spPr>
+        <p:txBody>
+          <a:bodyPr/>
+          <a:p/>
+        </p:txBody>
       </p:sp>
       <p:sp>
         <p:nvSpPr>
@@ -2927,7 +3136,7 @@
                 <a:ea typeface="Calibri" pitchFamily="34" charset="-122"/>
                 <a:cs typeface="Calibri" pitchFamily="34" charset="-120"/>
               </a:rPr>
-              <a:t>2-5 replicas</a:t>
+              <a:t>2-5 réplicas</a:t>
             </a:r>
             <a:endParaRPr lang="en-US" sz="1100" dirty="0"/>
           </a:p>
@@ -2944,7 +3153,7 @@
                 <a:ea typeface="Calibri" pitchFamily="34" charset="-122"/>
                 <a:cs typeface="Calibri" pitchFamily="34" charset="-120"/>
               </a:rPr>
-              <a:t>CPU target: 70%</a:t>
+              <a:t>Meta de CPU: 70%</a:t>
             </a:r>
             <a:endParaRPr lang="en-US" sz="1100" dirty="0"/>
           </a:p>
@@ -2976,6 +3185,10 @@
             </a:outerShdw>
           </a:effectLst>
         </p:spPr>
+        <p:txBody>
+          <a:bodyPr/>
+          <a:p/>
+        </p:txBody>
       </p:sp>
       <p:sp>
         <p:nvSpPr>
@@ -3105,7 +3318,7 @@
                 <a:ea typeface="Calibri" pitchFamily="34" charset="-122"/>
                 <a:cs typeface="Calibri" pitchFamily="34" charset="-120"/>
               </a:rPr>
-              <a:t>Protects against drain</a:t>
+              <a:t>Protege contra drenagem de nós</a:t>
             </a:r>
             <a:endParaRPr lang="en-US" sz="1100" dirty="0"/>
           </a:p>
@@ -3137,6 +3350,10 @@
             </a:outerShdw>
           </a:effectLst>
         </p:spPr>
+        <p:txBody>
+          <a:bodyPr/>
+          <a:p/>
+        </p:txBody>
       </p:sp>
       <p:sp>
         <p:nvSpPr>
@@ -3210,7 +3427,7 @@
                 <a:ea typeface="Calibri" pitchFamily="34" charset="-122"/>
                 <a:cs typeface="Calibri" pitchFamily="34" charset="-120"/>
               </a:rPr>
-              <a:t>Health Probes</a:t>
+              <a:t>Probes de Saúde</a:t>
             </a:r>
             <a:endParaRPr lang="en-US" sz="1400" dirty="0"/>
           </a:p>
@@ -3266,7 +3483,7 @@
                 <a:ea typeface="Calibri" pitchFamily="34" charset="-122"/>
                 <a:cs typeface="Calibri" pitchFamily="34" charset="-120"/>
               </a:rPr>
-              <a:t>on all services</a:t>
+              <a:t>em todos os serviços</a:t>
             </a:r>
             <a:endParaRPr lang="en-US" sz="1100" dirty="0"/>
           </a:p>
@@ -3298,6 +3515,10 @@
             </a:outerShdw>
           </a:effectLst>
         </p:spPr>
+        <p:txBody>
+          <a:bodyPr/>
+          <a:p/>
+        </p:txBody>
       </p:sp>
       <p:sp>
         <p:nvSpPr>
@@ -3371,7 +3592,7 @@
                 <a:ea typeface="Calibri" pitchFamily="34" charset="-122"/>
                 <a:cs typeface="Calibri" pitchFamily="34" charset="-120"/>
               </a:rPr>
-              <a:t>Replicas Each</a:t>
+              <a:t>Réplicas por Serviço</a:t>
             </a:r>
             <a:endParaRPr lang="en-US" sz="1400" dirty="0"/>
           </a:p>
@@ -3410,7 +3631,7 @@
                 <a:ea typeface="Calibri" pitchFamily="34" charset="-122"/>
                 <a:cs typeface="Calibri" pitchFamily="34" charset="-120"/>
               </a:rPr>
-              <a:t>High availability</a:t>
+              <a:t>Alta disponibilidade</a:t>
             </a:r>
             <a:endParaRPr lang="en-US" sz="1100" dirty="0"/>
           </a:p>
@@ -3427,7 +3648,7 @@
                 <a:ea typeface="Calibri" pitchFamily="34" charset="-122"/>
                 <a:cs typeface="Calibri" pitchFamily="34" charset="-120"/>
               </a:rPr>
-              <a:t>for all 5 services</a:t>
+              <a:t>para todos os 5 serviços</a:t>
             </a:r>
             <a:endParaRPr lang="en-US" sz="1100" dirty="0"/>
           </a:p>
@@ -3459,6 +3680,10 @@
             </a:outerShdw>
           </a:effectLst>
         </p:spPr>
+        <p:txBody>
+          <a:bodyPr/>
+          <a:p/>
+        </p:txBody>
       </p:sp>
       <p:sp>
         <p:nvSpPr>
@@ -3532,7 +3757,7 @@
                 <a:ea typeface="Calibri" pitchFamily="34" charset="-122"/>
                 <a:cs typeface="Calibri" pitchFamily="34" charset="-120"/>
               </a:rPr>
-              <a:t>EKS Nodes</a:t>
+              <a:t>Nós EKS</a:t>
             </a:r>
             <a:endParaRPr lang="en-US" sz="1400" dirty="0"/>
           </a:p>
@@ -3571,7 +3796,7 @@
                 <a:ea typeface="Calibri" pitchFamily="34" charset="-122"/>
                 <a:cs typeface="Calibri" pitchFamily="34" charset="-120"/>
               </a:rPr>
-              <a:t>Across 2 AZs</a:t>
+              <a:t>Em 2 zonas de disponibilidade</a:t>
             </a:r>
             <a:endParaRPr lang="en-US" sz="1100" dirty="0"/>
           </a:p>
@@ -3588,7 +3813,7 @@
                 <a:ea typeface="Calibri" pitchFamily="34" charset="-122"/>
                 <a:cs typeface="Calibri" pitchFamily="34" charset="-120"/>
               </a:rPr>
-              <a:t>for fault tolerance</a:t>
+              <a:t>para tolerância a falhas</a:t>
             </a:r>
             <a:endParaRPr lang="en-US" sz="1100" dirty="0"/>
           </a:p>
@@ -3659,7 +3884,7 @@
                 <a:ea typeface="Arial Black" pitchFamily="34" charset="-122"/>
                 <a:cs typeface="Arial Black" pitchFamily="34" charset="-120"/>
               </a:rPr>
-              <a:t>Repository &amp; Reproducibility</a:t>
+              <a:t>Repositório &amp; Reprodutibilidade</a:t>
             </a:r>
             <a:endParaRPr lang="en-US" sz="3600" dirty="0"/>
           </a:p>
@@ -3691,6 +3916,10 @@
             </a:outerShdw>
           </a:effectLst>
         </p:spPr>
+        <p:txBody>
+          <a:bodyPr/>
+          <a:p/>
+        </p:txBody>
       </p:sp>
       <p:sp>
         <p:nvSpPr>
@@ -3722,7 +3951,7 @@
                   <a:srgbClr val="000000"/>
                 </a:solidFill>
               </a:rPr>
-              <a:t>Fully Forkable Repository</a:t>
+              <a:t>Repositório Totalmente Reprodutível</a:t>
             </a:r>
             <a:endParaRPr lang="en-US" sz="1800" dirty="0"/>
           </a:p>
@@ -3742,7 +3971,7 @@
                   <a:srgbClr val="00D4AA"/>
                 </a:solidFill>
               </a:rPr>
-              <a:t>Placeholder System</a:t>
+              <a:t>Sistema de Placeholders</a:t>
             </a:r>
             <a:endParaRPr lang="en-US" sz="1800" dirty="0"/>
           </a:p>
@@ -3756,7 +3985,7 @@
                   <a:srgbClr val="94A3B8"/>
                 </a:solidFill>
               </a:rPr>
-              <a:t>Manifests use &lt;AWS_ACCOUNT_ID&gt; and &lt;GITHUB_USER&gt; placeholders</a:t>
+              <a:t>Os manifestos usam os placeholders &lt;AWS_ACCOUNT_ID&gt; e &lt;GITHUB_USER&gt;</a:t>
             </a:r>
             <a:endParaRPr lang="en-US" sz="1800" dirty="0"/>
           </a:p>
@@ -3770,7 +3999,7 @@
                   <a:srgbClr val="94A3B8"/>
                 </a:solidFill>
               </a:rPr>
-              <a:t>setup-full.sh replaces them, commits, and pushes automatically</a:t>
+              <a:t>O setup-full.sh os substitui, faz commit e push automaticamente</a:t>
             </a:r>
             <a:endParaRPr lang="en-US" sz="1800" dirty="0"/>
           </a:p>
@@ -3790,7 +4019,7 @@
                   <a:srgbClr val="00D4AA"/>
                 </a:solidFill>
               </a:rPr>
-              <a:t>One-Command Deploy</a:t>
+              <a:t>Deploy em Um Comando</a:t>
             </a:r>
             <a:endParaRPr lang="en-US" sz="1800" dirty="0"/>
           </a:p>
@@ -3821,7 +4050,7 @@
                   <a:srgbClr val="94A3B8"/>
                 </a:solidFill>
               </a:rPr>
-              <a:t>Provisions infra, builds images, deploys apps, installs monitoring</a:t>
+              <a:t>Provisiona infraestrutura, constrói imagens, implanta apps e instala monitoramento</a:t>
             </a:r>
             <a:endParaRPr lang="en-US" sz="1800" dirty="0"/>
           </a:p>
@@ -3841,7 +4070,7 @@
                   <a:srgbClr val="00D4AA"/>
                 </a:solidFill>
               </a:rPr>
-              <a:t>Clean Teardown</a:t>
+              <a:t>Remoção Limpa</a:t>
             </a:r>
             <a:endParaRPr lang="en-US" sz="1800" dirty="0"/>
           </a:p>
@@ -3872,7 +4101,7 @@
                   <a:srgbClr val="94A3B8"/>
                 </a:solidFill>
               </a:rPr>
-              <a:t>Destroys all resources, restores placeholders, commits back to repo</a:t>
+              <a:t>Destrói todos os recursos, restaura os placeholders e faz commit no repositório</a:t>
             </a:r>
             <a:endParaRPr lang="en-US" sz="1800" dirty="0"/>
           </a:p>
@@ -3929,6 +4158,10 @@
           </a:solidFill>
           <a:ln/>
         </p:spPr>
+        <p:txBody>
+          <a:bodyPr/>
+          <a:p/>
+        </p:txBody>
       </p:sp>
       <p:sp>
         <p:nvSpPr>
@@ -3963,7 +4196,7 @@
                 <a:ea typeface="Arial Black" pitchFamily="34" charset="-122"/>
                 <a:cs typeface="Arial Black" pitchFamily="34" charset="-120"/>
               </a:rPr>
-              <a:t>Summary</a:t>
+              <a:t>Resumo</a:t>
             </a:r>
             <a:endParaRPr lang="en-US" sz="3600" dirty="0"/>
           </a:p>
@@ -3988,6 +4221,10 @@
           </a:solidFill>
           <a:ln/>
         </p:spPr>
+        <p:txBody>
+          <a:bodyPr/>
+          <a:p/>
+        </p:txBody>
       </p:sp>
       <p:sp>
         <p:nvSpPr>
@@ -4061,7 +4298,7 @@
                 <a:ea typeface="Calibri" pitchFamily="34" charset="-122"/>
                 <a:cs typeface="Calibri" pitchFamily="34" charset="-120"/>
               </a:rPr>
-              <a:t>Full Observability</a:t>
+              <a:t>Observabilidade Total</a:t>
             </a:r>
             <a:endParaRPr lang="en-US" sz="1800" dirty="0"/>
           </a:p>
@@ -4100,7 +4337,7 @@
                 <a:ea typeface="Calibri" pitchFamily="34" charset="-122"/>
                 <a:cs typeface="Calibri" pitchFamily="34" charset="-120"/>
               </a:rPr>
-              <a:t>Metrics + Logs + Traces across all 5 services</a:t>
+              <a:t>Métricas + Logs + Rastreamentos em todos os 5 serviços</a:t>
             </a:r>
             <a:endParaRPr lang="en-US" sz="1300" dirty="0"/>
           </a:p>
@@ -4125,6 +4362,10 @@
           </a:solidFill>
           <a:ln/>
         </p:spPr>
+        <p:txBody>
+          <a:bodyPr/>
+          <a:p/>
+        </p:txBody>
       </p:sp>
       <p:sp>
         <p:nvSpPr>
@@ -4198,7 +4439,7 @@
                 <a:ea typeface="Calibri" pitchFamily="34" charset="-122"/>
                 <a:cs typeface="Calibri" pitchFamily="34" charset="-120"/>
               </a:rPr>
-              <a:t>Automated Alerting</a:t>
+              <a:t>Alertas Automatizados</a:t>
             </a:r>
             <a:endParaRPr lang="en-US" sz="1800" dirty="0"/>
           </a:p>
@@ -4237,7 +4478,7 @@
                 <a:ea typeface="Calibri" pitchFamily="34" charset="-122"/>
                 <a:cs typeface="Calibri" pitchFamily="34" charset="-120"/>
               </a:rPr>
-              <a:t>PagerDuty (critical) + Discord (all) with smart routing</a:t>
+              <a:t>PagerDuty (crítico) + Discord (todos) com roteamento inteligente</a:t>
             </a:r>
             <a:endParaRPr lang="en-US" sz="1300" dirty="0"/>
           </a:p>
@@ -4262,6 +4503,10 @@
           </a:solidFill>
           <a:ln/>
         </p:spPr>
+        <p:txBody>
+          <a:bodyPr/>
+          <a:p/>
+        </p:txBody>
       </p:sp>
       <p:sp>
         <p:nvSpPr>
@@ -4335,7 +4580,7 @@
                 <a:ea typeface="Calibri" pitchFamily="34" charset="-122"/>
                 <a:cs typeface="Calibri" pitchFamily="34" charset="-120"/>
               </a:rPr>
-              <a:t>Self-Healing</a:t>
+              <a:t>Auto-Recuperação</a:t>
             </a:r>
             <a:endParaRPr lang="en-US" sz="1800" dirty="0"/>
           </a:p>
@@ -4374,7 +4619,7 @@
                 <a:ea typeface="Calibri" pitchFamily="34" charset="-122"/>
                 <a:cs typeface="Calibri" pitchFamily="34" charset="-120"/>
               </a:rPr>
-              <a:t>Fault detection + auto-remediation via GitHub Actions</a:t>
+              <a:t>Detecção de falhas + auto-remediação via GitHub Actions</a:t>
             </a:r>
             <a:endParaRPr lang="en-US" sz="1300" dirty="0"/>
           </a:p>
@@ -4399,6 +4644,10 @@
           </a:solidFill>
           <a:ln/>
         </p:spPr>
+        <p:txBody>
+          <a:bodyPr/>
+          <a:p/>
+        </p:txBody>
       </p:sp>
       <p:sp>
         <p:nvSpPr>
@@ -4472,7 +4721,7 @@
                 <a:ea typeface="Calibri" pitchFamily="34" charset="-122"/>
                 <a:cs typeface="Calibri" pitchFamily="34" charset="-120"/>
               </a:rPr>
-              <a:t>Reproducible</a:t>
+              <a:t>Reprodutível</a:t>
             </a:r>
             <a:endParaRPr lang="en-US" sz="1800" dirty="0"/>
           </a:p>
@@ -4511,7 +4760,7 @@
                 <a:ea typeface="Calibri" pitchFamily="34" charset="-122"/>
                 <a:cs typeface="Calibri" pitchFamily="34" charset="-120"/>
               </a:rPr>
-              <a:t>Everything as code, forkable, one-command deploy</a:t>
+              <a:t>Tudo como código, copiável, deploy em um comando</a:t>
             </a:r>
             <a:endParaRPr lang="en-US" sz="1300" dirty="0"/>
           </a:p>
@@ -4550,7 +4799,7 @@
                 <a:ea typeface="Calibri" pitchFamily="34" charset="-122"/>
                 <a:cs typeface="Calibri" pitchFamily="34" charset="-120"/>
               </a:rPr>
-              <a:t>Thank you!</a:t>
+              <a:t>Obrigado!</a:t>
             </a:r>
             <a:endParaRPr lang="en-US" sz="2000" dirty="0"/>
           </a:p>
@@ -4699,7 +4948,7 @@
                 <a:ea typeface="Calibri" pitchFamily="34" charset="-122"/>
                 <a:cs typeface="Calibri" pitchFamily="34" charset="-120"/>
               </a:rPr>
-              <a:t>Architecture Overview</a:t>
+              <a:t>Visão Geral da Arquitetura</a:t>
             </a:r>
             <a:endParaRPr lang="en-US" sz="1600" dirty="0"/>
           </a:p>
@@ -4738,7 +4987,7 @@
                 <a:ea typeface="Calibri" pitchFamily="34" charset="-122"/>
                 <a:cs typeface="Calibri" pitchFamily="34" charset="-120"/>
               </a:rPr>
-              <a:t>EKS + ArgoCD + 5 microservices</a:t>
+              <a:t>EKS + ArgoCD + 5 microsserviços</a:t>
             </a:r>
             <a:endParaRPr lang="en-US" sz="1300" dirty="0"/>
           </a:p>
@@ -4855,7 +5104,7 @@
                 <a:ea typeface="Calibri" pitchFamily="34" charset="-122"/>
                 <a:cs typeface="Calibri" pitchFamily="34" charset="-120"/>
               </a:rPr>
-              <a:t>Monitoring Stack</a:t>
+              <a:t>Stack de Monitoramento</a:t>
             </a:r>
             <a:endParaRPr lang="en-US" sz="1600" dirty="0"/>
           </a:p>
@@ -5050,7 +5299,7 @@
                 <a:ea typeface="Calibri" pitchFamily="34" charset="-122"/>
                 <a:cs typeface="Calibri" pitchFamily="34" charset="-120"/>
               </a:rPr>
-              <a:t>Custom ecosystem health dashboard</a:t>
+              <a:t>Dashboard customizado de saúde do ecossistema</a:t>
             </a:r>
             <a:endParaRPr lang="en-US" sz="1300" dirty="0"/>
           </a:p>
@@ -5167,7 +5416,7 @@
                 <a:ea typeface="Calibri" pitchFamily="34" charset="-122"/>
                 <a:cs typeface="Calibri" pitchFamily="34" charset="-120"/>
               </a:rPr>
-              <a:t>APM &amp; Distributed Tracing</a:t>
+              <a:t>APM &amp; Rastreamento Distribuído</a:t>
             </a:r>
             <a:endParaRPr lang="en-US" sz="1600" dirty="0"/>
           </a:p>
@@ -5206,7 +5455,7 @@
                 <a:ea typeface="Calibri" pitchFamily="34" charset="-122"/>
                 <a:cs typeface="Calibri" pitchFamily="34" charset="-120"/>
               </a:rPr>
-              <a:t>New Relic: Service Map + Traces</a:t>
+              <a:t>New Relic: Mapa de Serviços + Rastreamentos</a:t>
             </a:r>
             <a:endParaRPr lang="en-US" sz="1300" dirty="0"/>
           </a:p>
@@ -5323,7 +5572,7 @@
                 <a:ea typeface="Calibri" pitchFamily="34" charset="-122"/>
                 <a:cs typeface="Calibri" pitchFamily="34" charset="-120"/>
               </a:rPr>
-              <a:t>Alerting Pipeline</a:t>
+              <a:t>Pipeline de Alertas</a:t>
             </a:r>
             <a:endParaRPr lang="en-US" sz="1600" dirty="0"/>
           </a:p>
@@ -5362,7 +5611,7 @@
                 <a:ea typeface="Calibri" pitchFamily="34" charset="-122"/>
                 <a:cs typeface="Calibri" pitchFamily="34" charset="-120"/>
               </a:rPr>
-              <a:t>PagerDuty + Discord + routing rules</a:t>
+              <a:t>PagerDuty + Discord + regras de roteamento</a:t>
             </a:r>
             <a:endParaRPr lang="en-US" sz="1300" dirty="0"/>
           </a:p>
@@ -5479,7 +5728,7 @@
                 <a:ea typeface="Calibri" pitchFamily="34" charset="-122"/>
                 <a:cs typeface="Calibri" pitchFamily="34" charset="-120"/>
               </a:rPr>
-              <a:t>Self-Healing Demo</a:t>
+              <a:t>Demo de Auto-Recuperação</a:t>
             </a:r>
             <a:endParaRPr lang="en-US" sz="1600" dirty="0"/>
           </a:p>
@@ -5518,7 +5767,7 @@
                 <a:ea typeface="Calibri" pitchFamily="34" charset="-122"/>
                 <a:cs typeface="Calibri" pitchFamily="34" charset="-120"/>
               </a:rPr>
-              <a:t>Fault injection + auto-remediation</a:t>
+              <a:t>Injeção de falhas + auto-remediação</a:t>
             </a:r>
             <a:endParaRPr lang="en-US" sz="1300" dirty="0"/>
           </a:p>
@@ -5635,7 +5884,7 @@
                 <a:ea typeface="Calibri" pitchFamily="34" charset="-122"/>
                 <a:cs typeface="Calibri" pitchFamily="34" charset="-120"/>
               </a:rPr>
-              <a:t>Technical Justifications</a:t>
+              <a:t>Justificativas Técnicas</a:t>
             </a:r>
             <a:endParaRPr lang="en-US" sz="1600" dirty="0"/>
           </a:p>
@@ -5674,7 +5923,7 @@
                 <a:ea typeface="Calibri" pitchFamily="34" charset="-122"/>
                 <a:cs typeface="Calibri" pitchFamily="34" charset="-120"/>
               </a:rPr>
-              <a:t>Why New Relic, PagerDuty, OTel</a:t>
+              <a:t>Por que New Relic, PagerDuty, OTel</a:t>
             </a:r>
             <a:endParaRPr lang="en-US" sz="1300" dirty="0"/>
           </a:p>
@@ -5784,7 +6033,7 @@
                 <a:ea typeface="Arial Black" pitchFamily="34" charset="-122"/>
                 <a:cs typeface="Arial Black" pitchFamily="34" charset="-120"/>
               </a:rPr>
-              <a:t>Architecture Overview</a:t>
+              <a:t>Visão Geral da Arquitetura</a:t>
             </a:r>
             <a:endParaRPr lang="en-US" sz="3600" dirty="0"/>
           </a:p>
@@ -5816,6 +6065,10 @@
             </a:outerShdw>
           </a:effectLst>
         </p:spPr>
+        <p:txBody>
+          <a:bodyPr/>
+          <a:p/>
+        </p:txBody>
       </p:sp>
       <p:sp>
         <p:nvSpPr>
@@ -5836,6 +6089,10 @@
           </a:solidFill>
           <a:ln/>
         </p:spPr>
+        <p:txBody>
+          <a:bodyPr/>
+          <a:p/>
+        </p:txBody>
       </p:sp>
       <p:sp>
         <p:nvSpPr>
@@ -5870,7 +6127,7 @@
                 <a:ea typeface="Calibri" pitchFamily="34" charset="-122"/>
                 <a:cs typeface="Calibri" pitchFamily="34" charset="-120"/>
               </a:rPr>
-              <a:t>Infrastructure</a:t>
+              <a:t>Infraestrutura</a:t>
             </a:r>
             <a:endParaRPr lang="en-US" sz="1800" dirty="0"/>
           </a:p>
@@ -5906,7 +6163,7 @@
                   <a:srgbClr val="000000"/>
                 </a:solidFill>
               </a:rPr>
-              <a:t>EKS Cluster</a:t>
+              <a:t>Cluster EKS</a:t>
             </a:r>
             <a:endParaRPr lang="en-US" sz="1400" dirty="0"/>
           </a:p>
@@ -5920,7 +6177,7 @@
                   <a:srgbClr val="94A3B8"/>
                 </a:solidFill>
               </a:rPr>
-              <a:t>3 nodes (t3.medium) across 2 AZs</a:t>
+              <a:t>3 nós (t3.medium) em 2 Zonas de Disponibilidade</a:t>
             </a:r>
             <a:endParaRPr lang="en-US" sz="1400" dirty="0"/>
           </a:p>
@@ -5988,7 +6245,7 @@
                   <a:srgbClr val="94A3B8"/>
                 </a:solidFill>
               </a:rPr>
-              <a:t>Auto-sync with self-heal, prune enabled</a:t>
+              <a:t>Auto-sincronização com auto-recuperação e prune ativados</a:t>
             </a:r>
             <a:endParaRPr lang="en-US" sz="1400" dirty="0"/>
           </a:p>
@@ -6020,6 +6277,10 @@
             </a:outerShdw>
           </a:effectLst>
         </p:spPr>
+        <p:txBody>
+          <a:bodyPr/>
+          <a:p/>
+        </p:txBody>
       </p:sp>
       <p:sp>
         <p:nvSpPr>
@@ -6040,6 +6301,10 @@
           </a:solidFill>
           <a:ln/>
         </p:spPr>
+        <p:txBody>
+          <a:bodyPr/>
+          <a:p/>
+        </p:txBody>
       </p:sp>
       <p:sp>
         <p:nvSpPr>
@@ -6074,7 +6339,7 @@
                 <a:ea typeface="Calibri" pitchFamily="34" charset="-122"/>
                 <a:cs typeface="Calibri" pitchFamily="34" charset="-120"/>
               </a:rPr>
-              <a:t>5 Microservices</a:t>
+              <a:t>5 Microsserviços</a:t>
             </a:r>
             <a:endParaRPr lang="en-US" sz="1800" dirty="0"/>
           </a:p>
@@ -6099,6 +6364,10 @@
           </a:solidFill>
           <a:ln/>
         </p:spPr>
+        <p:txBody>
+          <a:bodyPr/>
+          <a:p/>
+        </p:txBody>
       </p:sp>
       <p:sp>
         <p:nvSpPr>
@@ -6236,6 +6505,10 @@
           </a:solidFill>
           <a:ln/>
         </p:spPr>
+        <p:txBody>
+          <a:bodyPr/>
+          <a:p/>
+        </p:txBody>
       </p:sp>
       <p:sp>
         <p:nvSpPr>
@@ -6373,6 +6646,10 @@
           </a:solidFill>
           <a:ln/>
         </p:spPr>
+        <p:txBody>
+          <a:bodyPr/>
+          <a:p/>
+        </p:txBody>
       </p:sp>
       <p:sp>
         <p:nvSpPr>
@@ -6510,6 +6787,10 @@
           </a:solidFill>
           <a:ln/>
         </p:spPr>
+        <p:txBody>
+          <a:bodyPr/>
+          <a:p/>
+        </p:txBody>
       </p:sp>
       <p:sp>
         <p:nvSpPr>
@@ -6647,6 +6928,10 @@
           </a:solidFill>
           <a:ln/>
         </p:spPr>
+        <p:txBody>
+          <a:bodyPr/>
+          <a:p/>
+        </p:txBody>
       </p:sp>
       <p:sp>
         <p:nvSpPr>
@@ -6830,7 +7115,7 @@
                 <a:ea typeface="Arial Black" pitchFamily="34" charset="-122"/>
                 <a:cs typeface="Arial Black" pitchFamily="34" charset="-120"/>
               </a:rPr>
-              <a:t>Monitoring Stack</a:t>
+              <a:t>Stack de Monitoramento</a:t>
             </a:r>
             <a:endParaRPr lang="en-US" sz="3600" dirty="0"/>
           </a:p>
@@ -6862,6 +7147,10 @@
             </a:outerShdw>
           </a:effectLst>
         </p:spPr>
+        <p:txBody>
+          <a:bodyPr/>
+          <a:p/>
+        </p:txBody>
       </p:sp>
       <p:sp>
         <p:nvSpPr>
@@ -6882,6 +7171,10 @@
           </a:solidFill>
           <a:ln/>
         </p:spPr>
+        <p:txBody>
+          <a:bodyPr/>
+          <a:p/>
+        </p:txBody>
       </p:sp>
       <p:sp>
         <p:nvSpPr>
@@ -6955,7 +7248,7 @@
                 <a:ea typeface="Calibri" pitchFamily="34" charset="-122"/>
                 <a:cs typeface="Calibri" pitchFamily="34" charset="-120"/>
               </a:rPr>
-              <a:t>Time-series DB for metrics</a:t>
+              <a:t>Banco de dados de séries temporais para métricas</a:t>
             </a:r>
             <a:endParaRPr lang="en-US" sz="1100" dirty="0"/>
           </a:p>
@@ -6972,7 +7265,7 @@
                 <a:ea typeface="Calibri" pitchFamily="34" charset="-122"/>
                 <a:cs typeface="Calibri" pitchFamily="34" charset="-120"/>
               </a:rPr>
-              <a:t>CPU, memory, HTTP rates, histograms</a:t>
+              <a:t>CPU, memória, taxas HTTP, histogramas</a:t>
             </a:r>
             <a:endParaRPr lang="en-US" sz="1100" dirty="0"/>
           </a:p>
@@ -7004,6 +7297,10 @@
             </a:outerShdw>
           </a:effectLst>
         </p:spPr>
+        <p:txBody>
+          <a:bodyPr/>
+          <a:p/>
+        </p:txBody>
       </p:sp>
       <p:sp>
         <p:nvSpPr>
@@ -7024,6 +7321,10 @@
           </a:solidFill>
           <a:ln/>
         </p:spPr>
+        <p:txBody>
+          <a:bodyPr/>
+          <a:p/>
+        </p:txBody>
       </p:sp>
       <p:sp>
         <p:nvSpPr>
@@ -7097,7 +7398,7 @@
                 <a:ea typeface="Calibri" pitchFamily="34" charset="-122"/>
                 <a:cs typeface="Calibri" pitchFamily="34" charset="-120"/>
               </a:rPr>
-              <a:t>Log aggregation system</a:t>
+              <a:t>Sistema de agregação de logs</a:t>
             </a:r>
             <a:endParaRPr lang="en-US" sz="1100" dirty="0"/>
           </a:p>
@@ -7114,7 +7415,7 @@
                 <a:ea typeface="Calibri" pitchFamily="34" charset="-122"/>
                 <a:cs typeface="Calibri" pitchFamily="34" charset="-120"/>
               </a:rPr>
-              <a:t>Centralizes all container logs</a:t>
+              <a:t>Centraliza todos os logs dos contêineres</a:t>
             </a:r>
             <a:endParaRPr lang="en-US" sz="1100" dirty="0"/>
           </a:p>
@@ -7146,6 +7447,10 @@
             </a:outerShdw>
           </a:effectLst>
         </p:spPr>
+        <p:txBody>
+          <a:bodyPr/>
+          <a:p/>
+        </p:txBody>
       </p:sp>
       <p:sp>
         <p:nvSpPr>
@@ -7166,6 +7471,10 @@
           </a:solidFill>
           <a:ln/>
         </p:spPr>
+        <p:txBody>
+          <a:bodyPr/>
+          <a:p/>
+        </p:txBody>
       </p:sp>
       <p:sp>
         <p:nvSpPr>
@@ -7239,7 +7548,7 @@
                 <a:ea typeface="Calibri" pitchFamily="34" charset="-122"/>
                 <a:cs typeface="Calibri" pitchFamily="34" charset="-120"/>
               </a:rPr>
-              <a:t>Log collector (DaemonSet)</a:t>
+              <a:t>Coletor de logs (DaemonSet)</a:t>
             </a:r>
             <a:endParaRPr lang="en-US" sz="1100" dirty="0"/>
           </a:p>
@@ -7256,7 +7565,7 @@
                 <a:ea typeface="Calibri" pitchFamily="34" charset="-122"/>
                 <a:cs typeface="Calibri" pitchFamily="34" charset="-120"/>
               </a:rPr>
-              <a:t>Tails logs on each node, ships to Loki</a:t>
+              <a:t>Coleta logs em cada nó e envia para o Loki</a:t>
             </a:r>
             <a:endParaRPr lang="en-US" sz="1100" dirty="0"/>
           </a:p>
@@ -7288,6 +7597,10 @@
             </a:outerShdw>
           </a:effectLst>
         </p:spPr>
+        <p:txBody>
+          <a:bodyPr/>
+          <a:p/>
+        </p:txBody>
       </p:sp>
       <p:sp>
         <p:nvSpPr>
@@ -7308,6 +7621,10 @@
           </a:solidFill>
           <a:ln/>
         </p:spPr>
+        <p:txBody>
+          <a:bodyPr/>
+          <a:p/>
+        </p:txBody>
       </p:sp>
       <p:sp>
         <p:nvSpPr>
@@ -7381,7 +7698,7 @@
                 <a:ea typeface="Calibri" pitchFamily="34" charset="-122"/>
                 <a:cs typeface="Calibri" pitchFamily="34" charset="-120"/>
               </a:rPr>
-              <a:t>Visualization &amp; dashboards</a:t>
+              <a:t>Visualização e dashboards</a:t>
             </a:r>
             <a:endParaRPr lang="en-US" sz="1100" dirty="0"/>
           </a:p>
@@ -7398,7 +7715,7 @@
                 <a:ea typeface="Calibri" pitchFamily="34" charset="-122"/>
                 <a:cs typeface="Calibri" pitchFamily="34" charset="-120"/>
               </a:rPr>
-              <a:t>Single pane: metrics + logs</a:t>
+              <a:t>Painel único: métricas + logs</a:t>
             </a:r>
             <a:endParaRPr lang="en-US" sz="1100" dirty="0"/>
           </a:p>
@@ -7430,6 +7747,10 @@
             </a:outerShdw>
           </a:effectLst>
         </p:spPr>
+        <p:txBody>
+          <a:bodyPr/>
+          <a:p/>
+        </p:txBody>
       </p:sp>
       <p:sp>
         <p:nvSpPr>
@@ -7450,6 +7771,10 @@
           </a:solidFill>
           <a:ln/>
         </p:spPr>
+        <p:txBody>
+          <a:bodyPr/>
+          <a:p/>
+        </p:txBody>
       </p:sp>
       <p:sp>
         <p:nvSpPr>
@@ -7523,7 +7848,7 @@
                 <a:ea typeface="Calibri" pitchFamily="34" charset="-122"/>
                 <a:cs typeface="Calibri" pitchFamily="34" charset="-120"/>
               </a:rPr>
-              <a:t>Central telemetry router</a:t>
+              <a:t>Roteador central de telemetria</a:t>
             </a:r>
             <a:endParaRPr lang="en-US" sz="1100" dirty="0"/>
           </a:p>
@@ -7540,7 +7865,7 @@
                 <a:ea typeface="Calibri" pitchFamily="34" charset="-122"/>
                 <a:cs typeface="Calibri" pitchFamily="34" charset="-120"/>
               </a:rPr>
-              <a:t>Receives, processes, exports all data</a:t>
+              <a:t>Recebe, processa e exporta todos os dados</a:t>
             </a:r>
             <a:endParaRPr lang="en-US" sz="1100" dirty="0"/>
           </a:p>
@@ -7579,7 +7904,7 @@
                 <a:ea typeface="Calibri" pitchFamily="34" charset="-122"/>
                 <a:cs typeface="Calibri" pitchFamily="34" charset="-120"/>
               </a:rPr>
-              <a:t>All deployed via Helm charts in the monitoring namespace</a:t>
+              <a:t>Todos implantados via Helm charts no namespace monitoring</a:t>
             </a:r>
             <a:endParaRPr lang="en-US" sz="1200" dirty="0"/>
           </a:p>
@@ -7636,6 +7961,10 @@
           </a:solidFill>
           <a:ln/>
         </p:spPr>
+        <p:txBody>
+          <a:bodyPr/>
+          <a:p/>
+        </p:txBody>
       </p:sp>
       <p:sp>
         <p:nvSpPr>
@@ -7709,7 +8038,7 @@
                 <a:ea typeface="Calibri" pitchFamily="34" charset="-122"/>
                 <a:cs typeface="Calibri" pitchFamily="34" charset="-120"/>
               </a:rPr>
-              <a:t>The Central Router</a:t>
+              <a:t>O Roteador Central</a:t>
             </a:r>
             <a:endParaRPr lang="en-US" sz="1800" dirty="0"/>
           </a:p>
@@ -7734,6 +8063,10 @@
           </a:solidFill>
           <a:ln/>
         </p:spPr>
+        <p:txBody>
+          <a:bodyPr/>
+          <a:p/>
+        </p:txBody>
       </p:sp>
       <p:sp>
         <p:nvSpPr>
@@ -7768,7 +8101,7 @@
                 <a:ea typeface="Calibri" pitchFamily="34" charset="-122"/>
                 <a:cs typeface="Calibri" pitchFamily="34" charset="-120"/>
               </a:rPr>
-              <a:t>5 Microservices</a:t>
+              <a:t>5 Microsserviços</a:t>
             </a:r>
             <a:endParaRPr lang="en-US" sz="1200" dirty="0"/>
           </a:p>
@@ -7791,7 +8124,7 @@
                 <a:ea typeface="Calibri" pitchFamily="34" charset="-122"/>
                 <a:cs typeface="Calibri" pitchFamily="34" charset="-120"/>
               </a:rPr>
-              <a:t>OTLP Protocol</a:t>
+              <a:t>Protocolo OTLP</a:t>
             </a:r>
             <a:endParaRPr lang="en-US" sz="1200" dirty="0"/>
           </a:p>
@@ -7893,6 +8226,10 @@
             </a:outerShdw>
           </a:effectLst>
         </p:spPr>
+        <p:txBody>
+          <a:bodyPr/>
+          <a:p/>
+        </p:txBody>
       </p:sp>
       <p:sp>
         <p:nvSpPr>
@@ -7950,7 +8287,7 @@
                 <a:ea typeface="Calibri" pitchFamily="34" charset="-122"/>
                 <a:cs typeface="Calibri" pitchFamily="34" charset="-120"/>
               </a:rPr>
-              <a:t>Receivers</a:t>
+              <a:t>Receptores</a:t>
             </a:r>
             <a:endParaRPr lang="en-US" sz="1400" dirty="0"/>
           </a:p>
@@ -7967,7 +8304,7 @@
                 <a:ea typeface="Calibri" pitchFamily="34" charset="-122"/>
                 <a:cs typeface="Calibri" pitchFamily="34" charset="-120"/>
               </a:rPr>
-              <a:t>Processors</a:t>
+              <a:t>Processadores</a:t>
             </a:r>
             <a:endParaRPr lang="en-US" sz="1400" dirty="0"/>
           </a:p>
@@ -7984,7 +8321,7 @@
                 <a:ea typeface="Calibri" pitchFamily="34" charset="-122"/>
                 <a:cs typeface="Calibri" pitchFamily="34" charset="-120"/>
               </a:rPr>
-              <a:t>Exporters</a:t>
+              <a:t>Exportadores</a:t>
             </a:r>
             <a:endParaRPr lang="en-US" sz="1400" dirty="0"/>
           </a:p>
@@ -8045,6 +8382,10 @@
           </a:solidFill>
           <a:ln/>
         </p:spPr>
+        <p:txBody>
+          <a:bodyPr/>
+          <a:p/>
+        </p:txBody>
       </p:sp>
       <p:sp>
         <p:nvSpPr>
@@ -8090,7 +8431,7 @@
                   <a:srgbClr val="94A3B8"/>
                 </a:solidFill>
               </a:rPr>
-              <a:t>Traces + Metrics</a:t>
+              <a:t>Rastreamentos + Métricas</a:t>
             </a:r>
             <a:endParaRPr lang="en-US" sz="1300" dirty="0"/>
           </a:p>
@@ -8115,6 +8456,10 @@
           </a:solidFill>
           <a:ln/>
         </p:spPr>
+        <p:txBody>
+          <a:bodyPr/>
+          <a:p/>
+        </p:txBody>
       </p:sp>
       <p:sp>
         <p:nvSpPr>
@@ -8160,7 +8505,7 @@
                   <a:srgbClr val="94A3B8"/>
                 </a:solidFill>
               </a:rPr>
-              <a:t>Metrics</a:t>
+              <a:t>Métricas</a:t>
             </a:r>
             <a:endParaRPr lang="en-US" sz="1300" dirty="0"/>
           </a:p>
@@ -8185,6 +8530,10 @@
           </a:solidFill>
           <a:ln/>
         </p:spPr>
+        <p:txBody>
+          <a:bodyPr/>
+          <a:p/>
+        </p:txBody>
       </p:sp>
       <p:sp>
         <p:nvSpPr>
@@ -8269,7 +8618,7 @@
                 <a:ea typeface="Calibri" pitchFamily="34" charset="-122"/>
                 <a:cs typeface="Calibri" pitchFamily="34" charset="-120"/>
               </a:rPr>
-              <a:t>Why OTel? Vendor-neutral. Swap backends without touching application code.</a:t>
+              <a:t>Por que OTel? Independente de fornecedor. Troque backends sem alterar o código da aplicação.</a:t>
             </a:r>
             <a:endParaRPr lang="en-US" sz="1300" dirty="0"/>
           </a:p>
@@ -8379,7 +8728,7 @@
                 <a:ea typeface="Consolas" pitchFamily="34" charset="-122"/>
                 <a:cs typeface="Consolas" pitchFamily="34" charset="-120"/>
               </a:rPr>
-              <a:t>ToggleMaster - Ecosystem Health</a:t>
+              <a:t>ToggleMaster - Saúde do Ecossistema</a:t>
             </a:r>
             <a:endParaRPr lang="en-US" sz="1600" dirty="0"/>
           </a:p>
@@ -8411,6 +8760,10 @@
             </a:outerShdw>
           </a:effectLst>
         </p:spPr>
+        <p:txBody>
+          <a:bodyPr/>
+          <a:p/>
+        </p:txBody>
       </p:sp>
       <p:sp>
         <p:nvSpPr>
@@ -8445,7 +8798,7 @@
                 <a:ea typeface="Calibri" pitchFamily="34" charset="-122"/>
                 <a:cs typeface="Calibri" pitchFamily="34" charset="-120"/>
               </a:rPr>
-              <a:t>Node CPU %</a:t>
+              <a:t>CPU dos Nós %</a:t>
             </a:r>
             <a:endParaRPr lang="en-US" sz="1300" dirty="0"/>
           </a:p>
@@ -8484,7 +8837,7 @@
                 <a:ea typeface="Calibri" pitchFamily="34" charset="-122"/>
                 <a:cs typeface="Calibri" pitchFamily="34" charset="-120"/>
               </a:rPr>
-              <a:t>Per-node gauge with label_replace</a:t>
+              <a:t>Gauge por nó com label_replace</a:t>
             </a:r>
             <a:endParaRPr lang="en-US" sz="1000" dirty="0"/>
           </a:p>
@@ -8555,6 +8908,10 @@
             </a:outerShdw>
           </a:effectLst>
         </p:spPr>
+        <p:txBody>
+          <a:bodyPr/>
+          <a:p/>
+        </p:txBody>
       </p:sp>
       <p:sp>
         <p:nvSpPr>
@@ -8589,7 +8946,7 @@
                 <a:ea typeface="Calibri" pitchFamily="34" charset="-122"/>
                 <a:cs typeface="Calibri" pitchFamily="34" charset="-120"/>
               </a:rPr>
-              <a:t>Node Memory %</a:t>
+              <a:t>Memória dos Nós %</a:t>
             </a:r>
             <a:endParaRPr lang="en-US" sz="1300" dirty="0"/>
           </a:p>
@@ -8628,7 +8985,7 @@
                 <a:ea typeface="Calibri" pitchFamily="34" charset="-122"/>
                 <a:cs typeface="Calibri" pitchFamily="34" charset="-120"/>
               </a:rPr>
-              <a:t>Per-node gauge, IP without port</a:t>
+              <a:t>Gauge por nó, IP sem porta</a:t>
             </a:r>
             <a:endParaRPr lang="en-US" sz="1000" dirty="0"/>
           </a:p>
@@ -8699,6 +9056,10 @@
             </a:outerShdw>
           </a:effectLst>
         </p:spPr>
+        <p:txBody>
+          <a:bodyPr/>
+          <a:p/>
+        </p:txBody>
       </p:sp>
       <p:sp>
         <p:nvSpPr>
@@ -8733,7 +9094,7 @@
                 <a:ea typeface="Calibri" pitchFamily="34" charset="-122"/>
                 <a:cs typeface="Calibri" pitchFamily="34" charset="-120"/>
               </a:rPr>
-              <a:t>HTTP Request Rate</a:t>
+              <a:t>Taxa de Requisições HTTP</a:t>
             </a:r>
             <a:endParaRPr lang="en-US" sz="1300" dirty="0"/>
           </a:p>
@@ -8772,7 +9133,7 @@
                 <a:ea typeface="Calibri" pitchFamily="34" charset="-122"/>
                 <a:cs typeface="Calibri" pitchFamily="34" charset="-120"/>
               </a:rPr>
-              <a:t>By service (Go + Python metrics)</a:t>
+              <a:t>Por serviço (métricas Go + Python)</a:t>
             </a:r>
             <a:endParaRPr lang="en-US" sz="1000" dirty="0"/>
           </a:p>
@@ -8843,6 +9204,10 @@
             </a:outerShdw>
           </a:effectLst>
         </p:spPr>
+        <p:txBody>
+          <a:bodyPr/>
+          <a:p/>
+        </p:txBody>
       </p:sp>
       <p:sp>
         <p:nvSpPr>
@@ -8877,7 +9242,7 @@
                 <a:ea typeface="Calibri" pitchFamily="34" charset="-122"/>
                 <a:cs typeface="Calibri" pitchFamily="34" charset="-120"/>
               </a:rPr>
-              <a:t>HTTP Error Rate 5xx</a:t>
+              <a:t>Taxa de Erros HTTP 5xx</a:t>
             </a:r>
             <a:endParaRPr lang="en-US" sz="1300" dirty="0"/>
           </a:p>
@@ -8916,7 +9281,7 @@
                 <a:ea typeface="Calibri" pitchFamily="34" charset="-122"/>
                 <a:cs typeface="Calibri" pitchFamily="34" charset="-120"/>
               </a:rPr>
-              <a:t>By service, error status codes</a:t>
+              <a:t>Por serviço, códigos de status de erro</a:t>
             </a:r>
             <a:endParaRPr lang="en-US" sz="1000" dirty="0"/>
           </a:p>
@@ -8987,6 +9352,10 @@
             </a:outerShdw>
           </a:effectLst>
         </p:spPr>
+        <p:txBody>
+          <a:bodyPr/>
+          <a:p/>
+        </p:txBody>
       </p:sp>
       <p:sp>
         <p:nvSpPr>
@@ -9021,7 +9390,7 @@
                 <a:ea typeface="Calibri" pitchFamily="34" charset="-122"/>
                 <a:cs typeface="Calibri" pitchFamily="34" charset="-120"/>
               </a:rPr>
-              <a:t>HTTP Latency P95</a:t>
+              <a:t>Latência HTTP P95</a:t>
             </a:r>
             <a:endParaRPr lang="en-US" sz="1300" dirty="0"/>
           </a:p>
@@ -9060,7 +9429,7 @@
                 <a:ea typeface="Calibri" pitchFamily="34" charset="-122"/>
                 <a:cs typeface="Calibri" pitchFamily="34" charset="-120"/>
               </a:rPr>
-              <a:t>95th percentile response time</a:t>
+              <a:t>Tempo de resposta no percentil 95</a:t>
             </a:r>
             <a:endParaRPr lang="en-US" sz="1000" dirty="0"/>
           </a:p>
@@ -9131,6 +9500,10 @@
             </a:outerShdw>
           </a:effectLst>
         </p:spPr>
+        <p:txBody>
+          <a:bodyPr/>
+          <a:p/>
+        </p:txBody>
       </p:sp>
       <p:sp>
         <p:nvSpPr>
@@ -9165,7 +9538,7 @@
                 <a:ea typeface="Calibri" pitchFamily="34" charset="-122"/>
                 <a:cs typeface="Calibri" pitchFamily="34" charset="-120"/>
               </a:rPr>
-              <a:t>Live Logs</a:t>
+              <a:t>Logs em Tempo Real</a:t>
             </a:r>
             <a:endParaRPr lang="en-US" sz="1300" dirty="0"/>
           </a:p>
@@ -9204,7 +9577,7 @@
                 <a:ea typeface="Calibri" pitchFamily="34" charset="-122"/>
                 <a:cs typeface="Calibri" pitchFamily="34" charset="-120"/>
               </a:rPr>
-              <a:t>Real-time container logs</a:t>
+              <a:t>Logs de contêineres em tempo real</a:t>
             </a:r>
             <a:endParaRPr lang="en-US" sz="1000" dirty="0"/>
           </a:p>
@@ -9275,6 +9648,10 @@
             </a:outerShdw>
           </a:effectLst>
         </p:spPr>
+        <p:txBody>
+          <a:bodyPr/>
+          <a:p/>
+        </p:txBody>
       </p:sp>
       <p:sp>
         <p:nvSpPr>
@@ -9309,7 +9686,7 @@
                 <a:ea typeface="Calibri" pitchFamily="34" charset="-122"/>
                 <a:cs typeface="Calibri" pitchFamily="34" charset="-120"/>
               </a:rPr>
-              <a:t>Error Logs Only</a:t>
+              <a:t>Apenas Logs de Erro</a:t>
             </a:r>
             <a:endParaRPr lang="en-US" sz="1300" dirty="0"/>
           </a:p>
@@ -9348,7 +9725,7 @@
                 <a:ea typeface="Calibri" pitchFamily="34" charset="-122"/>
                 <a:cs typeface="Calibri" pitchFamily="34" charset="-120"/>
               </a:rPr>
-              <a:t>Filtered by error/warn keywords</a:t>
+              <a:t>Filtrado por palavras-chave de erro/aviso</a:t>
             </a:r>
             <a:endParaRPr lang="en-US" sz="1000" dirty="0"/>
           </a:p>
@@ -9419,6 +9796,10 @@
             </a:outerShdw>
           </a:effectLst>
         </p:spPr>
+        <p:txBody>
+          <a:bodyPr/>
+          <a:p/>
+        </p:txBody>
       </p:sp>
       <p:sp>
         <p:nvSpPr>
@@ -9453,7 +9834,7 @@
                 <a:ea typeface="Calibri" pitchFamily="34" charset="-122"/>
                 <a:cs typeface="Calibri" pitchFamily="34" charset="-120"/>
               </a:rPr>
-              <a:t>Active Pods</a:t>
+              <a:t>Pods Ativos</a:t>
             </a:r>
             <a:endParaRPr lang="en-US" sz="1300" dirty="0"/>
           </a:p>
@@ -9492,7 +9873,7 @@
                 <a:ea typeface="Calibri" pitchFamily="34" charset="-122"/>
                 <a:cs typeface="Calibri" pitchFamily="34" charset="-120"/>
               </a:rPr>
-              <a:t>Pod count per deployment</a:t>
+              <a:t>Contagem de pods por deployment</a:t>
             </a:r>
             <a:endParaRPr lang="en-US" sz="1000" dirty="0"/>
           </a:p>
@@ -9673,6 +10054,10 @@
             </a:outerShdw>
           </a:effectLst>
         </p:spPr>
+        <p:txBody>
+          <a:bodyPr/>
+          <a:p/>
+        </p:txBody>
       </p:sp>
       <p:sp>
         <p:nvSpPr>
@@ -9693,6 +10078,10 @@
           </a:solidFill>
           <a:ln/>
         </p:spPr>
+        <p:txBody>
+          <a:bodyPr/>
+          <a:p/>
+        </p:txBody>
       </p:sp>
       <p:sp>
         <p:nvSpPr>
@@ -9727,7 +10116,7 @@
                 <a:ea typeface="Calibri" pitchFamily="34" charset="-122"/>
                 <a:cs typeface="Calibri" pitchFamily="34" charset="-120"/>
               </a:rPr>
-              <a:t>Distributed Tracing</a:t>
+              <a:t>Rastreamento Distribuído</a:t>
             </a:r>
             <a:endParaRPr lang="en-US" sz="1800" dirty="0"/>
           </a:p>
@@ -9763,7 +10152,7 @@
                   <a:srgbClr val="1E293B"/>
                 </a:solidFill>
               </a:rPr>
-              <a:t>Follow a single request across all 5 services</a:t>
+              <a:t>Acompanhe uma única requisição por todos os 5 serviços</a:t>
             </a:r>
             <a:endParaRPr lang="en-US" sz="1300" dirty="0"/>
           </a:p>
@@ -9783,7 +10172,7 @@
                   <a:srgbClr val="1E293B"/>
                 </a:solidFill>
               </a:rPr>
-              <a:t>See exactly where time is spent:</a:t>
+              <a:t>Veja exatamente onde o tempo é gasto:</a:t>
             </a:r>
             <a:endParaRPr lang="en-US" sz="1300" dirty="0"/>
           </a:p>
@@ -9881,6 +10270,10 @@
             </a:outerShdw>
           </a:effectLst>
         </p:spPr>
+        <p:txBody>
+          <a:bodyPr/>
+          <a:p/>
+        </p:txBody>
       </p:sp>
       <p:sp>
         <p:nvSpPr>
@@ -9901,6 +10294,10 @@
           </a:solidFill>
           <a:ln/>
         </p:spPr>
+        <p:txBody>
+          <a:bodyPr/>
+          <a:p/>
+        </p:txBody>
       </p:sp>
       <p:sp>
         <p:nvSpPr>
@@ -9935,7 +10332,7 @@
                 <a:ea typeface="Calibri" pitchFamily="34" charset="-122"/>
                 <a:cs typeface="Calibri" pitchFamily="34" charset="-120"/>
               </a:rPr>
-              <a:t>Service Map</a:t>
+              <a:t>Mapa de Serviços</a:t>
             </a:r>
             <a:endParaRPr lang="en-US" sz="1800" dirty="0"/>
           </a:p>
@@ -9971,7 +10368,7 @@
                   <a:srgbClr val="1E293B"/>
                 </a:solidFill>
               </a:rPr>
-              <a:t>Visual dependency graph of all microservices</a:t>
+              <a:t>Gráfico visual de dependências de todos os microsserviços</a:t>
             </a:r>
             <a:endParaRPr lang="en-US" sz="1300" dirty="0"/>
           </a:p>
@@ -9991,7 +10388,7 @@
                   <a:srgbClr val="1E293B"/>
                 </a:solidFill>
               </a:rPr>
-              <a:t>Shows:</a:t>
+              <a:t>Mostra:</a:t>
             </a:r>
             <a:endParaRPr lang="en-US" sz="1300" dirty="0"/>
           </a:p>
@@ -10012,7 +10409,7 @@
                   <a:srgbClr val="1E293B"/>
                 </a:solidFill>
               </a:rPr>
-              <a:t>Which service calls which</a:t>
+              <a:t>Qual serviço chama qual</a:t>
             </a:r>
             <a:endParaRPr lang="en-US" sz="1300" dirty="0"/>
           </a:p>
@@ -10027,7 +10424,7 @@
                   <a:srgbClr val="1E293B"/>
                 </a:solidFill>
               </a:rPr>
-              <a:t>Latency on each edge</a:t>
+              <a:t>Latência em cada conexão</a:t>
             </a:r>
             <a:endParaRPr lang="en-US" sz="1300" dirty="0"/>
           </a:p>
@@ -10042,7 +10439,7 @@
                   <a:srgbClr val="1E293B"/>
                 </a:solidFill>
               </a:rPr>
-              <a:t>Error rates per connection</a:t>
+              <a:t>Taxas de erro por conexão</a:t>
             </a:r>
             <a:endParaRPr lang="en-US" sz="1300" dirty="0"/>
           </a:p>
@@ -10057,7 +10454,7 @@
                   <a:srgbClr val="1E293B"/>
                 </a:solidFill>
               </a:rPr>
-              <a:t>Health status per service</a:t>
+              <a:t>Status de saúde por serviço</a:t>
             </a:r>
             <a:endParaRPr lang="en-US" sz="1300" dirty="0"/>
           </a:p>
@@ -10096,7 +10493,7 @@
                 <a:ea typeface="Calibri" pitchFamily="34" charset="-122"/>
                 <a:cs typeface="Calibri" pitchFamily="34" charset="-120"/>
               </a:rPr>
-              <a:t>Why New Relic: free education tier, native OTLP ingest, no agent required in services</a:t>
+              <a:t>Por que New Relic: plano educacional gratuito, ingestão OTLP nativa, sem agente nos serviços</a:t>
             </a:r>
             <a:endParaRPr lang="en-US" sz="1200" dirty="0"/>
           </a:p>
@@ -10167,7 +10564,7 @@
                 <a:ea typeface="Arial Black" pitchFamily="34" charset="-122"/>
                 <a:cs typeface="Arial Black" pitchFamily="34" charset="-120"/>
               </a:rPr>
-              <a:t>Alerting Pipeline</a:t>
+              <a:t>Pipeline de Alertas</a:t>
             </a:r>
             <a:endParaRPr lang="en-US" sz="3600" dirty="0"/>
           </a:p>
@@ -10199,6 +10596,10 @@
             </a:outerShdw>
           </a:effectLst>
         </p:spPr>
+        <p:txBody>
+          <a:bodyPr/>
+          <a:p/>
+        </p:txBody>
       </p:sp>
       <p:sp>
         <p:nvSpPr>
@@ -10219,6 +10620,10 @@
           </a:solidFill>
           <a:ln/>
         </p:spPr>
+        <p:txBody>
+          <a:bodyPr/>
+          <a:p/>
+        </p:txBody>
       </p:sp>
       <p:sp>
         <p:nvSpPr>
@@ -10331,7 +10736,7 @@
                 <a:ea typeface="Calibri" pitchFamily="34" charset="-122"/>
                 <a:cs typeface="Calibri" pitchFamily="34" charset="-120"/>
               </a:rPr>
-              <a:t>CRITICAL</a:t>
+              <a:t>CRÍTICO</a:t>
             </a:r>
             <a:endParaRPr lang="en-US" sz="1000" dirty="0"/>
           </a:p>
@@ -10409,7 +10814,7 @@
                 <a:ea typeface="Calibri" pitchFamily="34" charset="-122"/>
                 <a:cs typeface="Calibri" pitchFamily="34" charset="-120"/>
               </a:rPr>
-              <a:t>CRITICAL</a:t>
+              <a:t>CRÍTICO</a:t>
             </a:r>
             <a:endParaRPr lang="en-US" sz="1000" dirty="0"/>
           </a:p>
@@ -10487,7 +10892,7 @@
                 <a:ea typeface="Calibri" pitchFamily="34" charset="-122"/>
                 <a:cs typeface="Calibri" pitchFamily="34" charset="-120"/>
               </a:rPr>
-              <a:t>WARNING</a:t>
+              <a:t>AVISO</a:t>
             </a:r>
             <a:endParaRPr lang="en-US" sz="1000" dirty="0"/>
           </a:p>
@@ -10565,7 +10970,7 @@
                 <a:ea typeface="Calibri" pitchFamily="34" charset="-122"/>
                 <a:cs typeface="Calibri" pitchFamily="34" charset="-120"/>
               </a:rPr>
-              <a:t>WARNING</a:t>
+              <a:t>AVISO</a:t>
             </a:r>
             <a:endParaRPr lang="en-US" sz="1000" dirty="0"/>
           </a:p>
@@ -10643,7 +11048,7 @@
                 <a:ea typeface="Calibri" pitchFamily="34" charset="-122"/>
                 <a:cs typeface="Calibri" pitchFamily="34" charset="-120"/>
               </a:rPr>
-              <a:t>WARNING</a:t>
+              <a:t>AVISO</a:t>
             </a:r>
             <a:endParaRPr lang="en-US" sz="1000" dirty="0"/>
           </a:p>
@@ -10721,7 +11126,7 @@
                 <a:ea typeface="Calibri" pitchFamily="34" charset="-122"/>
                 <a:cs typeface="Calibri" pitchFamily="34" charset="-120"/>
               </a:rPr>
-              <a:t>WARNING</a:t>
+              <a:t>AVISO</a:t>
             </a:r>
             <a:endParaRPr lang="en-US" sz="1000" dirty="0"/>
           </a:p>
@@ -10753,6 +11158,10 @@
             </a:outerShdw>
           </a:effectLst>
         </p:spPr>
+        <p:txBody>
+          <a:bodyPr/>
+          <a:p/>
+        </p:txBody>
       </p:sp>
       <p:sp>
         <p:nvSpPr>
@@ -10773,6 +11182,10 @@
           </a:solidFill>
           <a:ln/>
         </p:spPr>
+        <p:txBody>
+          <a:bodyPr/>
+          <a:p/>
+        </p:txBody>
       </p:sp>
       <p:sp>
         <p:nvSpPr>
@@ -10807,7 +11220,7 @@
                 <a:ea typeface="Calibri" pitchFamily="34" charset="-122"/>
                 <a:cs typeface="Calibri" pitchFamily="34" charset="-120"/>
               </a:rPr>
-              <a:t>Alertmanager Routing</a:t>
+              <a:t>Roteamento do Alertmanager</a:t>
             </a:r>
             <a:endParaRPr lang="en-US" sz="1600" dirty="0"/>
           </a:p>
@@ -10843,7 +11256,7 @@
                   <a:srgbClr val="EF4444"/>
                 </a:solidFill>
               </a:rPr>
-              <a:t>CRITICAL</a:t>
+              <a:t>CRÍTICO</a:t>
             </a:r>
             <a:endParaRPr lang="en-US" sz="1300" dirty="0"/>
           </a:p>
@@ -10857,7 +11270,7 @@
                   <a:srgbClr val="94A3B8"/>
                 </a:solidFill>
               </a:rPr>
-              <a:t>  PagerDuty + Discord + Self-Healing</a:t>
+              <a:t>  PagerDuty + Discord + Auto-Recuperação</a:t>
             </a:r>
             <a:endParaRPr lang="en-US" sz="1300" dirty="0"/>
           </a:p>
@@ -10877,7 +11290,7 @@
                   <a:srgbClr val="F59E0B"/>
                 </a:solidFill>
               </a:rPr>
-              <a:t>WARNING</a:t>
+              <a:t>AVISO</a:t>
             </a:r>
             <a:endParaRPr lang="en-US" sz="1300" dirty="0"/>
           </a:p>
@@ -10891,7 +11304,7 @@
                   <a:srgbClr val="94A3B8"/>
                 </a:solidFill>
               </a:rPr>
-              <a:t>  Discord only</a:t>
+              <a:t>  Apenas Discord</a:t>
             </a:r>
             <a:endParaRPr lang="en-US" sz="1300" dirty="0"/>
           </a:p>
@@ -10911,7 +11324,7 @@
                   <a:srgbClr val="94A3B8"/>
                 </a:solidFill>
               </a:rPr>
-              <a:t>SILENCED</a:t>
+              <a:t>SILENCIADO</a:t>
             </a:r>
             <a:endParaRPr lang="en-US" sz="1300" dirty="0"/>
           </a:p>
@@ -10964,7 +11377,7 @@
                 <a:ea typeface="Calibri" pitchFamily="34" charset="-122"/>
                 <a:cs typeface="Calibri" pitchFamily="34" charset="-120"/>
               </a:rPr>
-              <a:t>Discord uses Slack-compatible webhook format (URL + /slack suffix)</a:t>
+              <a:t>O Discord usa formato de webhook compatível com Slack (URL + sufixo /slack)</a:t>
             </a:r>
             <a:endParaRPr lang="en-US" sz="1100" dirty="0"/>
           </a:p>
@@ -11021,6 +11434,10 @@
           </a:solidFill>
           <a:ln/>
         </p:spPr>
+        <p:txBody>
+          <a:bodyPr/>
+          <a:p/>
+        </p:txBody>
       </p:sp>
       <p:sp>
         <p:nvSpPr>
@@ -11055,7 +11472,7 @@
                 <a:ea typeface="Arial Black" pitchFamily="34" charset="-122"/>
                 <a:cs typeface="Arial Black" pitchFamily="34" charset="-120"/>
               </a:rPr>
-              <a:t>Self-Healing Demo</a:t>
+              <a:t>Demo de Auto-Recuperação</a:t>
             </a:r>
             <a:endParaRPr lang="en-US" sz="3600" dirty="0"/>
           </a:p>
@@ -11094,7 +11511,7 @@
                 <a:ea typeface="Calibri" pitchFamily="34" charset="-122"/>
                 <a:cs typeface="Calibri" pitchFamily="34" charset="-120"/>
               </a:rPr>
-              <a:t>The Real Test</a:t>
+              <a:t>O Teste Real</a:t>
             </a:r>
             <a:endParaRPr lang="en-US" sz="1800" dirty="0"/>
           </a:p>
@@ -11119,6 +11536,10 @@
           </a:solidFill>
           <a:ln/>
         </p:spPr>
+        <p:txBody>
+          <a:bodyPr/>
+          <a:p/>
+        </p:txBody>
       </p:sp>
       <p:sp>
         <p:nvSpPr>
@@ -11139,6 +11560,10 @@
           </a:solidFill>
           <a:ln/>
         </p:spPr>
+        <p:txBody>
+          <a:bodyPr/>
+          <a:p/>
+        </p:txBody>
       </p:sp>
       <p:sp>
         <p:nvSpPr>
@@ -11212,7 +11637,7 @@
                 <a:ea typeface="Calibri" pitchFamily="34" charset="-122"/>
                 <a:cs typeface="Calibri" pitchFamily="34" charset="-120"/>
               </a:rPr>
-              <a:t>Inject Fault</a:t>
+              <a:t>Injetar Falha</a:t>
             </a:r>
             <a:endParaRPr lang="en-US" sz="1400" dirty="0"/>
           </a:p>
@@ -11346,6 +11771,10 @@
           </a:solidFill>
           <a:ln/>
         </p:spPr>
+        <p:txBody>
+          <a:bodyPr/>
+          <a:p/>
+        </p:txBody>
       </p:sp>
       <p:sp>
         <p:nvSpPr>
@@ -11366,6 +11795,10 @@
           </a:solidFill>
           <a:ln/>
         </p:spPr>
+        <p:txBody>
+          <a:bodyPr/>
+          <a:p/>
+        </p:txBody>
       </p:sp>
       <p:sp>
         <p:nvSpPr>
@@ -11439,7 +11872,7 @@
                 <a:ea typeface="Calibri" pitchFamily="34" charset="-122"/>
                 <a:cs typeface="Calibri" pitchFamily="34" charset="-120"/>
               </a:rPr>
-              <a:t>Alert Fires</a:t>
+              <a:t>Alerta Disparado</a:t>
             </a:r>
             <a:endParaRPr lang="en-US" sz="1400" dirty="0"/>
           </a:p>
@@ -11495,7 +11928,7 @@
                 <a:ea typeface="Calibri" pitchFamily="34" charset="-122"/>
                 <a:cs typeface="Calibri" pitchFamily="34" charset="-120"/>
               </a:rPr>
-              <a:t>detected by</a:t>
+              <a:t>detectado pelo</a:t>
             </a:r>
             <a:endParaRPr lang="en-US" sz="1100" dirty="0"/>
           </a:p>
@@ -11573,6 +12006,10 @@
           </a:solidFill>
           <a:ln/>
         </p:spPr>
+        <p:txBody>
+          <a:bodyPr/>
+          <a:p/>
+        </p:txBody>
       </p:sp>
       <p:sp>
         <p:nvSpPr>
@@ -11593,6 +12030,10 @@
           </a:solidFill>
           <a:ln/>
         </p:spPr>
+        <p:txBody>
+          <a:bodyPr/>
+          <a:p/>
+        </p:txBody>
       </p:sp>
       <p:sp>
         <p:nvSpPr>
@@ -11666,7 +12107,7 @@
                 <a:ea typeface="Calibri" pitchFamily="34" charset="-122"/>
                 <a:cs typeface="Calibri" pitchFamily="34" charset="-120"/>
               </a:rPr>
-              <a:t>Self-Heal</a:t>
+              <a:t>Auto-Recuperação</a:t>
             </a:r>
             <a:endParaRPr lang="en-US" sz="1400" dirty="0"/>
           </a:p>
@@ -11739,7 +12180,7 @@
                 <a:ea typeface="Calibri" pitchFamily="34" charset="-122"/>
                 <a:cs typeface="Calibri" pitchFamily="34" charset="-120"/>
               </a:rPr>
-              <a:t>automatically</a:t>
+              <a:t>automaticamente</a:t>
             </a:r>
             <a:endParaRPr lang="en-US" sz="1100" dirty="0"/>
           </a:p>
@@ -11800,6 +12241,10 @@
           </a:solidFill>
           <a:ln/>
         </p:spPr>
+        <p:txBody>
+          <a:bodyPr/>
+          <a:p/>
+        </p:txBody>
       </p:sp>
       <p:sp>
         <p:nvSpPr>
@@ -11820,6 +12265,10 @@
           </a:solidFill>
           <a:ln/>
         </p:spPr>
+        <p:txBody>
+          <a:bodyPr/>
+          <a:p/>
+        </p:txBody>
       </p:sp>
       <p:sp>
         <p:nvSpPr>
@@ -11893,7 +12342,7 @@
                 <a:ea typeface="Calibri" pitchFamily="34" charset="-122"/>
                 <a:cs typeface="Calibri" pitchFamily="34" charset="-120"/>
               </a:rPr>
-              <a:t>Recovered</a:t>
+              <a:t>Recuperado</a:t>
             </a:r>
             <a:endParaRPr lang="en-US" sz="1400" dirty="0"/>
           </a:p>
@@ -11932,7 +12381,7 @@
                 <a:ea typeface="Calibri" pitchFamily="34" charset="-122"/>
                 <a:cs typeface="Calibri" pitchFamily="34" charset="-120"/>
               </a:rPr>
-              <a:t>Pods back</a:t>
+              <a:t>Pods restaurados</a:t>
             </a:r>
             <a:endParaRPr lang="en-US" sz="1100" dirty="0"/>
           </a:p>
@@ -11949,7 +12398,7 @@
                 <a:ea typeface="Calibri" pitchFamily="34" charset="-122"/>
                 <a:cs typeface="Calibri" pitchFamily="34" charset="-120"/>
               </a:rPr>
-              <a:t>Discord notified</a:t>
+              <a:t>Discord notificado</a:t>
             </a:r>
             <a:endParaRPr lang="en-US" sz="1100" dirty="0"/>
           </a:p>
@@ -11966,7 +12415,7 @@
                 <a:ea typeface="Calibri" pitchFamily="34" charset="-122"/>
                 <a:cs typeface="Calibri" pitchFamily="34" charset="-120"/>
               </a:rPr>
-              <a:t>Incident resolved</a:t>
+              <a:t>Incidente resolvido</a:t>
             </a:r>
             <a:endParaRPr lang="en-US" sz="1100" dirty="0"/>
           </a:p>
@@ -12005,7 +12454,7 @@
                 <a:ea typeface="Calibri" pitchFamily="34" charset="-122"/>
                 <a:cs typeface="Calibri" pitchFamily="34" charset="-120"/>
               </a:rPr>
-              <a:t>Also in place: HPA (2-5 replicas) | PDB (minAvailable: 1) | Liveness + Readiness probes</a:t>
+              <a:t>Também disponíveis: HPA (2-5 réplicas) | PDB (minAvailable: 1) | Probes de Liveness + Readiness</a:t>
             </a:r>
             <a:endParaRPr lang="en-US" sz="1200" dirty="0"/>
           </a:p>
@@ -12044,7 +12493,7 @@
                 <a:ea typeface="Arial Black" pitchFamily="34" charset="-122"/>
                 <a:cs typeface="Arial Black" pitchFamily="34" charset="-120"/>
               </a:rPr>
-              <a:t>LIVE DEMO</a:t>
+              <a:t>DEMO AO VIVO</a:t>
             </a:r>
             <a:endParaRPr lang="en-US" sz="2000" dirty="0"/>
           </a:p>

</xml_diff>